<commit_message>
Perjelas slide P12 tentang loopTask dan rapikan istilah di slide lain
- P12: kalimat padat "(8.192 B, prioritas 1, inti 1)" diganti slide
  baru "Program Arduino-mu Juga Sebuah Task" yang menjelaskan stack 8 KB,
  prioritas 1, dan inti 1 beserta catatan dosen
- Perjelas butir slide yang terlalu padat di P02, P05, P08, P09, P10,
  P11, P12, dan P13
- Seragamkan istilah "bita" menjadi "byte" di P02 dan P15 (modul, kode,
  gambar, slide), dengan catatan ejaan KBBI pada definisi pertamanya

Co-Authored-By: Claude Opus 5.5 <noreply@anthropic.com>
Claude-Session: https://claude.ai/code/session_013QABXAq9cXfaV4J9WsCLkU
</commit_message>
<xml_diff>
--- a/slide/pptx/P02-Dasar-Pemrograman-C.pptx
+++ b/slide/pptx/P02-Dasar-Pemrograman-C.pptx
@@ -130,13 +130,13 @@
   <p:extLst>
     <p:ext uri="{521415D9-36F7-43E2-AB2F-B90AF26B5E84}">
       <p14:sectionLst xmlns:p14="http://schemas.microsoft.com/office/powerpoint/2010/main">
-        <p14:section name="Pembuka" id="{f073f534-4cb5-52cc-4103-355b11238d69}">
+        <p14:section name="Pembuka" id="{e1ee534d-7926-327b-299d-109bb6dcdc04}">
           <p14:sldIdLst>
             <p14:sldId id="256"/>
             <p14:sldId id="257"/>
           </p14:sldIdLst>
         </p14:section>
-        <p14:section name="Struktur" id="{fa7fe50c-7d8e-65da-18a7-e2aeb4549d78}">
+        <p14:section name="Struktur" id="{961a2bdd-6b23-b51d-936d-a59176f057bc}">
           <p14:sldIdLst>
             <p14:sldId id="258"/>
             <p14:sldId id="259"/>
@@ -145,7 +145,7 @@
             <p14:sldId id="262"/>
           </p14:sldIdLst>
         </p14:section>
-        <p14:section name="Data" id="{a0ec7586-ad1d-c1ba-35f0-d84c392e359f}">
+        <p14:section name="Data" id="{68486745-0df1-3b5c-a28b-eb4e8fcc8d16}">
           <p14:sldIdLst>
             <p14:sldId id="263"/>
             <p14:sldId id="264"/>
@@ -156,7 +156,7 @@
             <p14:sldId id="269"/>
           </p14:sldIdLst>
         </p14:section>
-        <p14:section name="Alur" id="{fd3d9a59-ae7b-e001-5984-1c01f8f18913}">
+        <p14:section name="Alur" id="{e6c0e715-df96-ae78-0583-541b0dbe268c}">
           <p14:sldIdLst>
             <p14:sldId id="270"/>
             <p14:sldId id="271"/>
@@ -168,7 +168,7 @@
             <p14:sldId id="277"/>
           </p14:sldIdLst>
         </p14:section>
-        <p14:section name="Penutup" id="{cd285421-7ca9-32aa-3a3b-8d2be4cd7c9f}">
+        <p14:section name="Penutup" id="{a47b6aa0-424b-6475-c9b5-b9bc0d6c4b72}">
           <p14:sldIdLst>
             <p14:sldId id="278"/>
             <p14:sldId id="279"/>
@@ -666,7 +666,7 @@
           <a:p>
             <a:r>
               <a:rPr lang="en-US" dirty="0"/>
-              <a:t>Di Arduino Uno int hanya 2 bita; karena itu pakai tipe berukuran pasti (uint8_t, int16_t, uint32_t). ESP32 punya FPU untuk float; double diemulasikan perangkat lunak sehingga lambat (ESP-IDF "Maximizing Execution Speed"). Cakupan: global, lokal, static (lokal yang diingat antarpemanggilan).</a:t>
+              <a:t>Di Arduino Uno int hanya 2 byte; karena itu pakai tipe berukuran pasti (uint8_t, int16_t, uint32_t). ESP32 punya FPU untuk float; double diemulasikan perangkat lunak sehingga lambat (ESP-IDF "Maximizing Execution Speed"). Cakupan: global, lokal, static (lokal yang diingat antarpemanggilan).</a:t>
             </a:r>
             <a:endParaRPr lang="en-US" dirty="0"/>
           </a:p>
@@ -4204,7 +4204,7 @@
                             <a:schemeClr val="tx1"/>
                           </a:solidFill>
                         </a:rPr>
-                        <a:t>1 bita</a:t>
+                        <a:t>1 byte</a:t>
                       </a:r>
                       <a:endParaRPr lang="en-US" sz="1600" dirty="0"/>
                     </a:p>
@@ -4389,7 +4389,7 @@
                             <a:schemeClr val="tx1"/>
                           </a:solidFill>
                         </a:rPr>
-                        <a:t>2 bita</a:t>
+                        <a:t>2 byte</a:t>
                       </a:r>
                       <a:endParaRPr lang="en-US" sz="1600" dirty="0"/>
                     </a:p>
@@ -4574,7 +4574,7 @@
                             <a:schemeClr val="tx1"/>
                           </a:solidFill>
                         </a:rPr>
-                        <a:t>4 bita</a:t>
+                        <a:t>4 byte</a:t>
                       </a:r>
                       <a:endParaRPr lang="en-US" sz="1600" dirty="0"/>
                     </a:p>
@@ -4759,7 +4759,7 @@
                             <a:schemeClr val="tx1"/>
                           </a:solidFill>
                         </a:rPr>
-                        <a:t>4 bita</a:t>
+                        <a:t>4 byte</a:t>
                       </a:r>
                       <a:endParaRPr lang="en-US" sz="1600" dirty="0"/>
                     </a:p>
@@ -4944,7 +4944,7 @@
                             <a:schemeClr val="tx1"/>
                           </a:solidFill>
                         </a:rPr>
-                        <a:t>4 bita</a:t>
+                        <a:t>4 byte</a:t>
                       </a:r>
                       <a:endParaRPr lang="en-US" sz="1600" dirty="0"/>
                     </a:p>
@@ -5129,7 +5129,7 @@
                             <a:schemeClr val="tx1"/>
                           </a:solidFill>
                         </a:rPr>
-                        <a:t>8 bita</a:t>
+                        <a:t>8 byte</a:t>
                       </a:r>
                       <a:endParaRPr lang="en-US" sz="1600" dirty="0"/>
                     </a:p>
@@ -11600,13 +11600,37 @@
             <a:r>
               <a:rPr lang="en-US" sz="2000" dirty="0">
                 <a:solidFill>
+                  <a:schemeClr val="bg1"/>
+                </a:solidFill>
+              </a:rPr>
+              <a:t>Di ESP32, </a:t>
+            </a:r>
+            <a:r>
+              <a:rPr lang="en-US" sz="2000" i="1" dirty="0">
+                <a:solidFill>
+                  <a:schemeClr val="bg1"/>
+                </a:solidFill>
+              </a:rPr>
+              <a:t>task</a:t>
+            </a:r>
+            <a:r>
+              <a:rPr lang="en-US" sz="2000" dirty="0">
+                <a:solidFill>
+                  <a:schemeClr val="bg1"/>
+                </a:solidFill>
+              </a:rPr>
+              <a:t> </a:t>
+            </a:r>
+            <a:r>
+              <a:rPr lang="en-US" sz="2000" dirty="0">
+                <a:solidFill>
                   <a:srgbClr val="F2C98A"/>
                 </a:solidFill>
                 <a:latin typeface="Consolas" pitchFamily="34" charset="0"/>
                 <a:ea typeface="Consolas" pitchFamily="34" charset="-122"/>
                 <a:cs typeface="Consolas" pitchFamily="34" charset="-120"/>
               </a:rPr>
-              <a:t>app_main()</a:t>
+              <a:t>loopTask</a:t>
             </a:r>
             <a:r>
               <a:rPr lang="en-US" sz="2000" dirty="0">
@@ -11614,61 +11638,26 @@
                   <a:schemeClr val="bg1"/>
                 </a:solidFill>
               </a:rPr>
-              <a:t> → </a:t>
-            </a:r>
-            <a:r>
-              <a:rPr lang="en-US" sz="2000" i="1" dirty="0">
+              <a:t> menjalankan </a:t>
+            </a:r>
+            <a:r>
+              <a:rPr lang="en-US" sz="2000" dirty="0">
+                <a:solidFill>
+                  <a:srgbClr val="F2C98A"/>
+                </a:solidFill>
+                <a:latin typeface="Consolas" pitchFamily="34" charset="0"/>
+                <a:ea typeface="Consolas" pitchFamily="34" charset="-122"/>
+                <a:cs typeface="Consolas" pitchFamily="34" charset="-120"/>
+              </a:rPr>
+              <a:t>setup()</a:t>
+            </a:r>
+            <a:r>
+              <a:rPr lang="en-US" sz="2000" dirty="0">
                 <a:solidFill>
                   <a:schemeClr val="bg1"/>
                 </a:solidFill>
               </a:rPr>
-              <a:t>task</a:t>
-            </a:r>
-            <a:r>
-              <a:rPr lang="en-US" sz="2000" dirty="0">
-                <a:solidFill>
-                  <a:schemeClr val="bg1"/>
-                </a:solidFill>
-              </a:rPr>
-              <a:t> </a:t>
-            </a:r>
-            <a:r>
-              <a:rPr lang="en-US" sz="2000" dirty="0">
-                <a:solidFill>
-                  <a:srgbClr val="F2C98A"/>
-                </a:solidFill>
-                <a:latin typeface="Consolas" pitchFamily="34" charset="0"/>
-                <a:ea typeface="Consolas" pitchFamily="34" charset="-122"/>
-                <a:cs typeface="Consolas" pitchFamily="34" charset="-120"/>
-              </a:rPr>
-              <a:t>loopTask</a:t>
-            </a:r>
-            <a:r>
-              <a:rPr lang="en-US" sz="2000" dirty="0">
-                <a:solidFill>
-                  <a:schemeClr val="bg1"/>
-                </a:solidFill>
-              </a:rPr>
-              <a:t>: </a:t>
-            </a:r>
-            <a:r>
-              <a:rPr lang="en-US" sz="2000" dirty="0">
-                <a:solidFill>
-                  <a:srgbClr val="F2C98A"/>
-                </a:solidFill>
-                <a:latin typeface="Consolas" pitchFamily="34" charset="0"/>
-                <a:ea typeface="Consolas" pitchFamily="34" charset="-122"/>
-                <a:cs typeface="Consolas" pitchFamily="34" charset="-120"/>
-              </a:rPr>
-              <a:t>setup()</a:t>
-            </a:r>
-            <a:r>
-              <a:rPr lang="en-US" sz="2000" dirty="0">
-                <a:solidFill>
-                  <a:schemeClr val="bg1"/>
-                </a:solidFill>
-              </a:rPr>
-              <a:t> sekali, </a:t>
+              <a:t> sekali, lalu </a:t>
             </a:r>
             <a:r>
               <a:rPr lang="en-US" sz="2000" dirty="0">
@@ -11895,7 +11884,7 @@
                   <a:schemeClr val="bg1"/>
                 </a:solidFill>
               </a:rPr>
-              <a:t>Ukuran ESP32: </a:t>
+              <a:t>Di ESP32, </a:t>
             </a:r>
             <a:r>
               <a:rPr lang="en-US" sz="2000" dirty="0">
@@ -11914,7 +11903,7 @@
                   <a:schemeClr val="bg1"/>
                 </a:solidFill>
               </a:rPr>
-              <a:t>/</a:t>
+              <a:t> dan </a:t>
             </a:r>
             <a:r>
               <a:rPr lang="en-US" sz="2000" dirty="0">
@@ -11933,7 +11922,7 @@
                   <a:schemeClr val="bg1"/>
                 </a:solidFill>
               </a:rPr>
-              <a:t> 4 bita, </a:t>
+              <a:t> berukuran 4 byte, </a:t>
             </a:r>
             <a:r>
               <a:rPr lang="en-US" sz="2000" dirty="0">
@@ -11952,7 +11941,7 @@
                   <a:schemeClr val="bg1"/>
                 </a:solidFill>
               </a:rPr>
-              <a:t> 8 bita; cek dengan </a:t>
+              <a:t> 8 byte; cek dengan </a:t>
             </a:r>
             <a:r>
               <a:rPr lang="en-US" sz="2000" dirty="0">
@@ -11963,7 +11952,7 @@
                 <a:ea typeface="Consolas" pitchFamily="34" charset="-122"/>
                 <a:cs typeface="Consolas" pitchFamily="34" charset="-120"/>
               </a:rPr>
-              <a:t>sizeof</a:t>
+              <a:t>sizeof()</a:t>
             </a:r>
             <a:endParaRPr lang="en-US" sz="2000" dirty="0"/>
           </a:p>
@@ -12187,7 +12176,7 @@
                   <a:schemeClr val="bg1"/>
                 </a:solidFill>
               </a:rPr>
-              <a:t>Bit: </a:t>
+              <a:t>Operator bit: </a:t>
             </a:r>
             <a:r>
               <a:rPr lang="en-US" sz="2000" dirty="0">
@@ -12206,7 +12195,7 @@
                   <a:schemeClr val="bg1"/>
                 </a:solidFill>
               </a:rPr>
-              <a:t> nyalakan, </a:t>
+              <a:t> menyalakan, </a:t>
             </a:r>
             <a:r>
               <a:rPr lang="en-US" sz="2000" dirty="0">
@@ -12225,7 +12214,7 @@
                   <a:schemeClr val="bg1"/>
                 </a:solidFill>
               </a:rPr>
-              <a:t> padamkan, </a:t>
+              <a:t> memadamkan, </a:t>
             </a:r>
             <a:r>
               <a:rPr lang="en-US" sz="2000" dirty="0">
@@ -12244,7 +12233,7 @@
                   <a:schemeClr val="bg1"/>
                 </a:solidFill>
               </a:rPr>
-              <a:t> balik</a:t>
+              <a:t> membalik bit</a:t>
             </a:r>
             <a:endParaRPr lang="en-US" sz="2000" dirty="0"/>
           </a:p>
@@ -12326,13 +12315,21 @@
             <a:r>
               <a:rPr lang="en-US" sz="2000" dirty="0">
                 <a:solidFill>
+                  <a:schemeClr val="bg1"/>
+                </a:solidFill>
+              </a:rPr>
+              <a:t>Cetak dengan </a:t>
+            </a:r>
+            <a:r>
+              <a:rPr lang="en-US" sz="2000" dirty="0">
+                <a:solidFill>
                   <a:srgbClr val="F2C98A"/>
                 </a:solidFill>
                 <a:latin typeface="Consolas" pitchFamily="34" charset="0"/>
                 <a:ea typeface="Consolas" pitchFamily="34" charset="-122"/>
                 <a:cs typeface="Consolas" pitchFamily="34" charset="-120"/>
               </a:rPr>
-              <a:t>printf</a:t>
+              <a:t>printf()</a:t>
             </a:r>
             <a:r>
               <a:rPr lang="en-US" sz="2000" dirty="0">
@@ -12340,7 +12337,7 @@
                   <a:schemeClr val="bg1"/>
                 </a:solidFill>
               </a:rPr>
-              <a:t> + kode format; input: </a:t>
+              <a:t> dan kode format; baca input dengan </a:t>
             </a:r>
             <a:r>
               <a:rPr lang="en-US" sz="2000" dirty="0">
@@ -12351,7 +12348,7 @@
                 <a:ea typeface="Consolas" pitchFamily="34" charset="-122"/>
                 <a:cs typeface="Consolas" pitchFamily="34" charset="-120"/>
               </a:rPr>
-              <a:t>readStringUntil</a:t>
+              <a:t>readStringUntil()</a:t>
             </a:r>
             <a:r>
               <a:rPr lang="en-US" sz="2000" dirty="0">
@@ -12359,7 +12356,7 @@
                   <a:schemeClr val="bg1"/>
                 </a:solidFill>
               </a:rPr>
-              <a:t> + </a:t>
+              <a:t>, </a:t>
             </a:r>
             <a:r>
               <a:rPr lang="en-US" sz="2000" dirty="0">
@@ -12370,7 +12367,7 @@
                 <a:ea typeface="Consolas" pitchFamily="34" charset="-122"/>
                 <a:cs typeface="Consolas" pitchFamily="34" charset="-120"/>
               </a:rPr>
-              <a:t>trim</a:t>
+              <a:t>trim()</a:t>
             </a:r>
             <a:r>
               <a:rPr lang="en-US" sz="2000" dirty="0">
@@ -12378,7 +12375,7 @@
                   <a:schemeClr val="bg1"/>
                 </a:solidFill>
               </a:rPr>
-              <a:t> + </a:t>
+              <a:t>, lalu </a:t>
             </a:r>
             <a:r>
               <a:rPr lang="en-US" sz="2000" dirty="0">
@@ -12389,7 +12386,7 @@
                 <a:ea typeface="Consolas" pitchFamily="34" charset="-122"/>
                 <a:cs typeface="Consolas" pitchFamily="34" charset="-120"/>
               </a:rPr>
-              <a:t>toInt</a:t>
+              <a:t>toInt()</a:t>
             </a:r>
             <a:endParaRPr lang="en-US" sz="2000" dirty="0"/>
           </a:p>

</xml_diff>